<commit_message>
fix(pptx): titres slides 14+15 (remarques/souhaits) — Calibri 24 bold explicite
Round 2 a patché les titres Q5-Q10 mais pas ceux des slides "Vos remarques"
et "Vos souhaits" (Rectangle 2 sans font explicite). Cross-PPTX clone perdait
l'inheritance du master source → titre rendu en police géante du master cible.

Co-Authored-By: Claude Opus 4.7 (1M context) <noreply@anthropic.com>
</commit_message>
<xml_diff>
--- a/templates/analysis-block.pptx
+++ b/templates/analysis-block.pptx
@@ -40824,7 +40824,12 @@
               <a:defRPr/>
             </a:pPr>
             <a:r>
-              <a:rPr lang="fr-FR" dirty="0"/>
+              <a:rPr lang="fr-FR" dirty="0" sz="2400" b="1">
+                <a:solidFill>
+                  <a:srgbClr val="000000"/>
+                </a:solidFill>
+                <a:latin typeface="Calibri"/>
+              </a:rPr>
               <a:t>Vos remarques et suggestions : (ce que vous avez bien aimé / ou pas aimé…)</a:t>
             </a:r>
           </a:p>
@@ -41000,7 +41005,12 @@
               <a:defRPr/>
             </a:pPr>
             <a:r>
-              <a:rPr lang="fr-FR" dirty="0"/>
+              <a:rPr lang="fr-FR" dirty="0" sz="2400" b="1">
+                <a:solidFill>
+                  <a:srgbClr val="000000"/>
+                </a:solidFill>
+                <a:latin typeface="Calibri"/>
+              </a:rPr>
               <a:t>Vos souhaits pour d’autres formations :</a:t>
             </a:r>
           </a:p>

</xml_diff>

<commit_message>
fix(pptx): titres slides 14+15 (remarques/souhaits) — Calibri 24 bold explicite (#7)
Round 2 a patché les titres Q5-Q10 mais pas ceux des slides "Vos remarques"
et "Vos souhaits" (Rectangle 2 sans font explicite). Cross-PPTX clone perdait
l'inheritance du master source → titre rendu en police géante du master cible.

Co-authored-by: Claude Opus 4.7 (1M context) <noreply@anthropic.com>
</commit_message>
<xml_diff>
--- a/templates/analysis-block.pptx
+++ b/templates/analysis-block.pptx
@@ -40824,7 +40824,12 @@
               <a:defRPr/>
             </a:pPr>
             <a:r>
-              <a:rPr lang="fr-FR" dirty="0"/>
+              <a:rPr lang="fr-FR" dirty="0" sz="2400" b="1">
+                <a:solidFill>
+                  <a:srgbClr val="000000"/>
+                </a:solidFill>
+                <a:latin typeface="Calibri"/>
+              </a:rPr>
               <a:t>Vos remarques et suggestions : (ce que vous avez bien aimé / ou pas aimé…)</a:t>
             </a:r>
           </a:p>
@@ -41000,7 +41005,12 @@
               <a:defRPr/>
             </a:pPr>
             <a:r>
-              <a:rPr lang="fr-FR" dirty="0"/>
+              <a:rPr lang="fr-FR" dirty="0" sz="2400" b="1">
+                <a:solidFill>
+                  <a:srgbClr val="000000"/>
+                </a:solidFill>
+                <a:latin typeface="Calibri"/>
+              </a:rPr>
               <a:t>Vos souhaits pour d’autres formations :</a:t>
             </a:r>
           </a:p>

</xml_diff>

<commit_message>
fix(pptx): feedback Inès — puces, taille comm, étiquettes wrap, charts uniformes (v2.4.0)
Feedback livraison prod Pic 13/05 :
- Slides 6-15 commentaires : ajout puces PIC (Wingdings 'q' bleu) + bump
  taille 14 → 16pt via _apply_pic_bullet() helper
- Slide 16 Vos remarques : puces forcées au paragraphe (héritage layout perdu
  cross-PPTX clone, cf. memory feedback_pptx_cross_merge_fonts)
- Étiquettes données : bodyPr wrap="none" pour décocher "Renvoyer texte à la
  ligne dans la forme" (sinon valeurs split en 2 lignes)
- Charts Q1-Q10 uniformisés à 22.58 × 11.17 cm (format Q4 existant) via
  scripts/patch_analysis_block_chart_size.py — applique aux 9 slides qui
  étaient à 22.58 × 15.05

Reste à diagnostiquer après nouveau test : "carré jaune slide 6" (peut être
masqué par uniformisation des tailles, sinon hypothèse légende manuelle
Groupe 22 / Image10 jaune visible quand Satisfait=0).

Co-Authored-By: Claude Opus 4.7 (1M context) <noreply@anthropic.com>
</commit_message>
<xml_diff>
--- a/templates/analysis-block.pptx
+++ b/templates/analysis-block.pptx
@@ -39361,7 +39361,7 @@
         </p:nvGraphicFramePr>
         <p:xfrm>
           <a:off x="633234" y="871111"/>
-          <a:ext cx="8128000" cy="5418667"/>
+          <a:ext cx="8128799" cy="4021200"/>
         </p:xfrm>
         <a:graphic>
           <a:graphicData uri="http://schemas.openxmlformats.org/drawingml/2006/chart">
@@ -39979,7 +39979,7 @@
         </p:nvGraphicFramePr>
         <p:xfrm>
           <a:off x="633234" y="871111"/>
-          <a:ext cx="8128000" cy="5418667"/>
+          <a:ext cx="8128799" cy="4021200"/>
         </p:xfrm>
         <a:graphic>
           <a:graphicData uri="http://schemas.openxmlformats.org/drawingml/2006/chart">
@@ -40597,7 +40597,7 @@
         </p:nvGraphicFramePr>
         <p:xfrm>
           <a:off x="633234" y="871111"/>
-          <a:ext cx="8128000" cy="5418667"/>
+          <a:ext cx="8128799" cy="4021200"/>
         </p:xfrm>
         <a:graphic>
           <a:graphicData uri="http://schemas.openxmlformats.org/drawingml/2006/chart">
@@ -41215,7 +41215,7 @@
         </p:nvGraphicFramePr>
         <p:xfrm>
           <a:off x="633234" y="871111"/>
-          <a:ext cx="8128000" cy="5418667"/>
+          <a:ext cx="8128799" cy="4021200"/>
         </p:xfrm>
         <a:graphic>
           <a:graphicData uri="http://schemas.openxmlformats.org/drawingml/2006/chart">
@@ -42989,7 +42989,7 @@
         </p:nvGraphicFramePr>
         <p:xfrm>
           <a:off x="633234" y="871111"/>
-          <a:ext cx="8128000" cy="5418667"/>
+          <a:ext cx="8128799" cy="4021200"/>
         </p:xfrm>
         <a:graphic>
           <a:graphicData uri="http://schemas.openxmlformats.org/drawingml/2006/chart">
@@ -43591,7 +43591,7 @@
         </p:nvGraphicFramePr>
         <p:xfrm>
           <a:off x="633234" y="871111"/>
-          <a:ext cx="8128000" cy="5418667"/>
+          <a:ext cx="8128799" cy="4021200"/>
         </p:xfrm>
         <a:graphic>
           <a:graphicData uri="http://schemas.openxmlformats.org/drawingml/2006/chart">
@@ -44193,7 +44193,7 @@
         </p:nvGraphicFramePr>
         <p:xfrm>
           <a:off x="633234" y="871111"/>
-          <a:ext cx="8128000" cy="5418667"/>
+          <a:ext cx="8128799" cy="4021200"/>
         </p:xfrm>
         <a:graphic>
           <a:graphicData uri="http://schemas.openxmlformats.org/drawingml/2006/chart">
@@ -45490,7 +45490,7 @@
         </p:nvGraphicFramePr>
         <p:xfrm>
           <a:off x="633234" y="871111"/>
-          <a:ext cx="8128000" cy="5418667"/>
+          <a:ext cx="8128799" cy="4021200"/>
         </p:xfrm>
         <a:graphic>
           <a:graphicData uri="http://schemas.openxmlformats.org/drawingml/2006/chart">
@@ -46108,7 +46108,7 @@
         </p:nvGraphicFramePr>
         <p:xfrm>
           <a:off x="633234" y="871111"/>
-          <a:ext cx="8128000" cy="5418667"/>
+          <a:ext cx="8128799" cy="4021200"/>
         </p:xfrm>
         <a:graphic>
           <a:graphicData uri="http://schemas.openxmlformats.org/drawingml/2006/chart">

</xml_diff>

<commit_message>
fix(pptx): strip manualLayout figés sur plotArea + dLbls (Q4 décalages)
Feedback Inès 14/05 : sur Q4, micro décalage du camembert + label % décalé
à gauche au lieu d'être centré. Cause = le template avait été calibré
manuellement dans PowerPoint pour les valeurs spécifiques du PDF EXEMPLE
original. Les <c:layout><c:manualLayout> de plotArea + dLbls étaient figés
dans le XML, donc s'appliquaient sur n'importe quel jeu de données →
positions absurdes quand les distributions diffèrent.

Strip de 20 <c:layout> au total (10 charts × 2 = plotArea + dLbl idx=0).
PowerPoint auto-positionne désormais pie + labels selon les vraies valeurs.

Co-Authored-By: Claude Opus 4.7 (1M context) <noreply@anthropic.com>
</commit_message>
<xml_diff>
--- a/templates/analysis-block.pptx
+++ b/templates/analysis-block.pptx
@@ -929,17 +929,6 @@
       </c:spPr>
     </c:backWall>
     <c:plotArea>
-      <c:layout>
-        <c:manualLayout>
-          <c:layoutTarget val="inner"/>
-          <c:xMode val="edge"/>
-          <c:yMode val="edge"/>
-          <c:x val="5.6250000000000001E-2"/>
-          <c:y val="8.8281121537824719E-2"/>
-          <c:w val="0.84062499999999996"/>
-          <c:h val="0.82343775692435062"/>
-        </c:manualLayout>
-      </c:layout>
       <c:pie3DChart>
         <c:varyColors val="1"/>
         <c:ser>
@@ -1059,12 +1048,6 @@
           <c:dLbls>
             <c:dLbl>
               <c:idx val="0"/>
-              <c:layout>
-                <c:manualLayout>
-                  <c:x val="-7.8125000000000004E-4"/>
-                  <c:y val="-0.44531247260627022"/>
-                </c:manualLayout>
-              </c:layout>
               <c:spPr>
                 <a:noFill/>
                 <a:ln>
@@ -1504,17 +1487,6 @@
       </c:spPr>
     </c:backWall>
     <c:plotArea>
-      <c:layout>
-        <c:manualLayout>
-          <c:layoutTarget val="inner"/>
-          <c:xMode val="edge"/>
-          <c:yMode val="edge"/>
-          <c:x val="5.6250000000000001E-2"/>
-          <c:y val="8.8281121537824719E-2"/>
-          <c:w val="0.84062499999999996"/>
-          <c:h val="0.82343775692435062"/>
-        </c:manualLayout>
-      </c:layout>
       <c:pie3DChart>
         <c:varyColors val="1"/>
         <c:ser>
@@ -1634,12 +1606,6 @@
           <c:dLbls>
             <c:dLbl>
               <c:idx val="0"/>
-              <c:layout>
-                <c:manualLayout>
-                  <c:x val="-7.8125000000000004E-4"/>
-                  <c:y val="-0.44531247260627022"/>
-                </c:manualLayout>
-              </c:layout>
               <c:spPr>
                 <a:noFill/>
                 <a:ln>
@@ -2079,17 +2045,6 @@
       </c:spPr>
     </c:backWall>
     <c:plotArea>
-      <c:layout>
-        <c:manualLayout>
-          <c:layoutTarget val="inner"/>
-          <c:xMode val="edge"/>
-          <c:yMode val="edge"/>
-          <c:x val="5.6250000000000001E-2"/>
-          <c:y val="8.8281121537824719E-2"/>
-          <c:w val="0.84062499999999996"/>
-          <c:h val="0.82343775692435062"/>
-        </c:manualLayout>
-      </c:layout>
       <c:pie3DChart>
         <c:varyColors val="1"/>
         <c:ser>
@@ -2209,12 +2164,6 @@
           <c:dLbls>
             <c:dLbl>
               <c:idx val="0"/>
-              <c:layout>
-                <c:manualLayout>
-                  <c:x val="-7.8125000000000004E-4"/>
-                  <c:y val="-0.44531247260627022"/>
-                </c:manualLayout>
-              </c:layout>
               <c:spPr>
                 <a:noFill/>
                 <a:ln>
@@ -2654,17 +2603,6 @@
       </c:spPr>
     </c:backWall>
     <c:plotArea>
-      <c:layout>
-        <c:manualLayout>
-          <c:layoutTarget val="inner"/>
-          <c:xMode val="edge"/>
-          <c:yMode val="edge"/>
-          <c:x val="5.6250000000000001E-2"/>
-          <c:y val="8.8281121537824719E-2"/>
-          <c:w val="0.84062499999999996"/>
-          <c:h val="0.82343775692435062"/>
-        </c:manualLayout>
-      </c:layout>
       <c:pie3DChart>
         <c:varyColors val="1"/>
         <c:ser>
@@ -2784,12 +2722,6 @@
           <c:dLbls>
             <c:dLbl>
               <c:idx val="0"/>
-              <c:layout>
-                <c:manualLayout>
-                  <c:x val="-7.8125000000000004E-4"/>
-                  <c:y val="-0.44531247260627022"/>
-                </c:manualLayout>
-              </c:layout>
               <c:spPr>
                 <a:noFill/>
                 <a:ln>
@@ -3229,17 +3161,6 @@
       </c:spPr>
     </c:backWall>
     <c:plotArea>
-      <c:layout>
-        <c:manualLayout>
-          <c:layoutTarget val="inner"/>
-          <c:xMode val="edge"/>
-          <c:yMode val="edge"/>
-          <c:x val="5.3125307548469641E-2"/>
-          <c:y val="9.4597632547498256E-2"/>
-          <c:w val="0.84062499999999996"/>
-          <c:h val="0.82343775692435062"/>
-        </c:manualLayout>
-      </c:layout>
       <c:pie3DChart>
         <c:varyColors val="1"/>
         <c:ser>
@@ -3359,12 +3280,6 @@
           <c:dLbls>
             <c:dLbl>
               <c:idx val="0"/>
-              <c:layout>
-                <c:manualLayout>
-                  <c:x val="-0.22732149886822164"/>
-                  <c:y val="-0.35056475678901816"/>
-                </c:manualLayout>
-              </c:layout>
               <c:spPr>
                 <a:noFill/>
                 <a:ln>
@@ -3809,17 +3724,6 @@
       </c:spPr>
     </c:backWall>
     <c:plotArea>
-      <c:layout>
-        <c:manualLayout>
-          <c:layoutTarget val="inner"/>
-          <c:xMode val="edge"/>
-          <c:yMode val="edge"/>
-          <c:x val="5.6250000000000001E-2"/>
-          <c:y val="8.8281121537824719E-2"/>
-          <c:w val="0.84062499999999996"/>
-          <c:h val="0.82343775692435062"/>
-        </c:manualLayout>
-      </c:layout>
       <c:pie3DChart>
         <c:varyColors val="1"/>
         <c:ser>
@@ -3939,12 +3843,6 @@
           <c:dLbls>
             <c:dLbl>
               <c:idx val="0"/>
-              <c:layout>
-                <c:manualLayout>
-                  <c:x val="-7.8125000000000004E-4"/>
-                  <c:y val="-0.44531247260627022"/>
-                </c:manualLayout>
-              </c:layout>
               <c:spPr>
                 <a:noFill/>
                 <a:ln>
@@ -4384,17 +4282,6 @@
       </c:spPr>
     </c:backWall>
     <c:plotArea>
-      <c:layout>
-        <c:manualLayout>
-          <c:layoutTarget val="inner"/>
-          <c:xMode val="edge"/>
-          <c:yMode val="edge"/>
-          <c:x val="5.6250000000000001E-2"/>
-          <c:y val="8.8281121537824719E-2"/>
-          <c:w val="0.84062499999999996"/>
-          <c:h val="0.82343775692435062"/>
-        </c:manualLayout>
-      </c:layout>
       <c:pie3DChart>
         <c:varyColors val="1"/>
         <c:ser>
@@ -4514,12 +4401,6 @@
           <c:dLbls>
             <c:dLbl>
               <c:idx val="0"/>
-              <c:layout>
-                <c:manualLayout>
-                  <c:x val="-7.8125000000000004E-4"/>
-                  <c:y val="-0.44531247260627022"/>
-                </c:manualLayout>
-              </c:layout>
               <c:spPr>
                 <a:noFill/>
                 <a:ln>
@@ -4959,17 +4840,6 @@
       </c:spPr>
     </c:backWall>
     <c:plotArea>
-      <c:layout>
-        <c:manualLayout>
-          <c:layoutTarget val="inner"/>
-          <c:xMode val="edge"/>
-          <c:yMode val="edge"/>
-          <c:x val="5.6250000000000001E-2"/>
-          <c:y val="8.8281121537824719E-2"/>
-          <c:w val="0.84062499999999996"/>
-          <c:h val="0.82343775692435062"/>
-        </c:manualLayout>
-      </c:layout>
       <c:pie3DChart>
         <c:varyColors val="1"/>
         <c:ser>
@@ -5089,12 +4959,6 @@
           <c:dLbls>
             <c:dLbl>
               <c:idx val="0"/>
-              <c:layout>
-                <c:manualLayout>
-                  <c:x val="-7.8125000000000004E-4"/>
-                  <c:y val="-0.44531247260627022"/>
-                </c:manualLayout>
-              </c:layout>
               <c:spPr>
                 <a:noFill/>
                 <a:ln>
@@ -5534,17 +5398,6 @@
       </c:spPr>
     </c:backWall>
     <c:plotArea>
-      <c:layout>
-        <c:manualLayout>
-          <c:layoutTarget val="inner"/>
-          <c:xMode val="edge"/>
-          <c:yMode val="edge"/>
-          <c:x val="5.6250000000000001E-2"/>
-          <c:y val="8.8281121537824719E-2"/>
-          <c:w val="0.84062499999999996"/>
-          <c:h val="0.82343775692435062"/>
-        </c:manualLayout>
-      </c:layout>
       <c:pie3DChart>
         <c:varyColors val="1"/>
         <c:ser>
@@ -5664,12 +5517,6 @@
           <c:dLbls>
             <c:dLbl>
               <c:idx val="0"/>
-              <c:layout>
-                <c:manualLayout>
-                  <c:x val="-7.8125000000000004E-4"/>
-                  <c:y val="-0.44531247260627022"/>
-                </c:manualLayout>
-              </c:layout>
               <c:spPr>
                 <a:noFill/>
                 <a:ln>
@@ -6109,17 +5956,6 @@
       </c:spPr>
     </c:backWall>
     <c:plotArea>
-      <c:layout>
-        <c:manualLayout>
-          <c:layoutTarget val="inner"/>
-          <c:xMode val="edge"/>
-          <c:yMode val="edge"/>
-          <c:x val="5.6250000000000001E-2"/>
-          <c:y val="8.8281121537824719E-2"/>
-          <c:w val="0.84062499999999996"/>
-          <c:h val="0.82343775692435062"/>
-        </c:manualLayout>
-      </c:layout>
       <c:pie3DChart>
         <c:varyColors val="1"/>
         <c:ser>
@@ -6239,12 +6075,6 @@
           <c:dLbls>
             <c:dLbl>
               <c:idx val="0"/>
-              <c:layout>
-                <c:manualLayout>
-                  <c:x val="-7.8125000000000004E-4"/>
-                  <c:y val="-0.44531247260627022"/>
-                </c:manualLayout>
-              </c:layout>
               <c:spPr>
                 <a:noFill/>
                 <a:ln>

</xml_diff>

<commit_message>
fix(pptx): force dLblPos=ctr sur séries (régression post-strip layouts)
Feedback Inès 14/05 (3e iter) : après strip-layouts, les labels N (xx %)
ne sont plus centrés sur les slices, surtout sur 100%. Cause = sans
manualLayout figé, PowerPoint fallback sur le dLblPos du chart pour
positionner. Le template n'avait aucun dLblPos défini → PowerPoint
utilise une heuristique (bestFit ou autre) qui place le label n'importe où.

Fix : force <c:dLblPos val="ctr"/> sur chaque <c:ser>/<c:dLbls>.
Le label est désormais systématiquement centré dans la slice (ou au
centre du pie quand 100%).

Trade-off accepté : on perd le placement fin que le template avait pour
EXEMPLE 1 MALECOT (manualLayout calibrés pour CETTE distribution
spécifique) — désormais le placement est uniforme et déterministe sur
toutes les distributions.

Co-Authored-By: Claude Opus 4.7 (1M context) <noreply@anthropic.com>
</commit_message>
<xml_diff>
--- a/templates/analysis-block.pptx
+++ b/templates/analysis-block.pptx
@@ -1161,6 +1161,7 @@
                 <a:endParaRPr lang="fr-FR"/>
               </a:p>
             </c:txPr>
+            <c:dLblPos val="ctr"/>
             <c:showLegendKey val="0"/>
             <c:showVal val="1"/>
             <c:showCatName val="0"/>
@@ -1719,6 +1720,7 @@
                 <a:endParaRPr lang="fr-FR"/>
               </a:p>
             </c:txPr>
+            <c:dLblPos val="ctr"/>
             <c:showLegendKey val="0"/>
             <c:showVal val="1"/>
             <c:showCatName val="0"/>
@@ -2277,6 +2279,7 @@
                 <a:endParaRPr lang="fr-FR"/>
               </a:p>
             </c:txPr>
+            <c:dLblPos val="ctr"/>
             <c:showLegendKey val="0"/>
             <c:showVal val="1"/>
             <c:showCatName val="0"/>
@@ -2835,6 +2838,7 @@
                 <a:endParaRPr lang="fr-FR"/>
               </a:p>
             </c:txPr>
+            <c:dLblPos val="ctr"/>
             <c:showLegendKey val="0"/>
             <c:showVal val="1"/>
             <c:showCatName val="0"/>
@@ -3398,6 +3402,7 @@
                 <a:endParaRPr lang="fr-FR"/>
               </a:p>
             </c:txPr>
+            <c:dLblPos val="ctr"/>
             <c:showLegendKey val="0"/>
             <c:showVal val="1"/>
             <c:showCatName val="0"/>
@@ -3956,6 +3961,7 @@
                 <a:endParaRPr lang="fr-FR"/>
               </a:p>
             </c:txPr>
+            <c:dLblPos val="ctr"/>
             <c:showLegendKey val="0"/>
             <c:showVal val="1"/>
             <c:showCatName val="0"/>
@@ -4514,6 +4520,7 @@
                 <a:endParaRPr lang="fr-FR"/>
               </a:p>
             </c:txPr>
+            <c:dLblPos val="ctr"/>
             <c:showLegendKey val="0"/>
             <c:showVal val="1"/>
             <c:showCatName val="0"/>
@@ -5072,6 +5079,7 @@
                 <a:endParaRPr lang="fr-FR"/>
               </a:p>
             </c:txPr>
+            <c:dLblPos val="ctr"/>
             <c:showLegendKey val="0"/>
             <c:showVal val="1"/>
             <c:showCatName val="0"/>
@@ -5630,6 +5638,7 @@
                 <a:endParaRPr lang="fr-FR"/>
               </a:p>
             </c:txPr>
+            <c:dLblPos val="ctr"/>
             <c:showLegendKey val="0"/>
             <c:showVal val="1"/>
             <c:showCatName val="0"/>
@@ -6188,6 +6197,7 @@
                 <a:endParaRPr lang="fr-FR"/>
               </a:p>
             </c:txPr>
+            <c:dLblPos val="ctr"/>
             <c:showLegendKey val="0"/>
             <c:showVal val="1"/>
             <c:showCatName val="0"/>

</xml_diff>

<commit_message>
Revert "fix(pptx): force dLblPos=ctr sur séries (régression post-strip layouts)"
This reverts commit fbf0fc45dbae80b415b7762ac702ac43639a4c5c.
</commit_message>
<xml_diff>
--- a/templates/analysis-block.pptx
+++ b/templates/analysis-block.pptx
@@ -1161,7 +1161,6 @@
                 <a:endParaRPr lang="fr-FR"/>
               </a:p>
             </c:txPr>
-            <c:dLblPos val="ctr"/>
             <c:showLegendKey val="0"/>
             <c:showVal val="1"/>
             <c:showCatName val="0"/>
@@ -1720,7 +1719,6 @@
                 <a:endParaRPr lang="fr-FR"/>
               </a:p>
             </c:txPr>
-            <c:dLblPos val="ctr"/>
             <c:showLegendKey val="0"/>
             <c:showVal val="1"/>
             <c:showCatName val="0"/>
@@ -2279,7 +2277,6 @@
                 <a:endParaRPr lang="fr-FR"/>
               </a:p>
             </c:txPr>
-            <c:dLblPos val="ctr"/>
             <c:showLegendKey val="0"/>
             <c:showVal val="1"/>
             <c:showCatName val="0"/>
@@ -2838,7 +2835,6 @@
                 <a:endParaRPr lang="fr-FR"/>
               </a:p>
             </c:txPr>
-            <c:dLblPos val="ctr"/>
             <c:showLegendKey val="0"/>
             <c:showVal val="1"/>
             <c:showCatName val="0"/>
@@ -3402,7 +3398,6 @@
                 <a:endParaRPr lang="fr-FR"/>
               </a:p>
             </c:txPr>
-            <c:dLblPos val="ctr"/>
             <c:showLegendKey val="0"/>
             <c:showVal val="1"/>
             <c:showCatName val="0"/>
@@ -3961,7 +3956,6 @@
                 <a:endParaRPr lang="fr-FR"/>
               </a:p>
             </c:txPr>
-            <c:dLblPos val="ctr"/>
             <c:showLegendKey val="0"/>
             <c:showVal val="1"/>
             <c:showCatName val="0"/>
@@ -4520,7 +4514,6 @@
                 <a:endParaRPr lang="fr-FR"/>
               </a:p>
             </c:txPr>
-            <c:dLblPos val="ctr"/>
             <c:showLegendKey val="0"/>
             <c:showVal val="1"/>
             <c:showCatName val="0"/>
@@ -5079,7 +5072,6 @@
                 <a:endParaRPr lang="fr-FR"/>
               </a:p>
             </c:txPr>
-            <c:dLblPos val="ctr"/>
             <c:showLegendKey val="0"/>
             <c:showVal val="1"/>
             <c:showCatName val="0"/>
@@ -5638,7 +5630,6 @@
                 <a:endParaRPr lang="fr-FR"/>
               </a:p>
             </c:txPr>
-            <c:dLblPos val="ctr"/>
             <c:showLegendKey val="0"/>
             <c:showVal val="1"/>
             <c:showCatName val="0"/>
@@ -6197,7 +6188,6 @@
                 <a:endParaRPr lang="fr-FR"/>
               </a:p>
             </c:txPr>
-            <c:dLblPos val="ctr"/>
             <c:showLegendKey val="0"/>
             <c:showVal val="1"/>
             <c:showCatName val="0"/>

</xml_diff>

<commit_message>
Revert "fix(pptx): strip manualLayout figés sur plotArea + dLbls (Q4 décalages)"
This reverts commit ec7e15d06eb15f80a226036ab387c239e90ae773.
</commit_message>
<xml_diff>
--- a/templates/analysis-block.pptx
+++ b/templates/analysis-block.pptx
@@ -929,6 +929,17 @@
       </c:spPr>
     </c:backWall>
     <c:plotArea>
+      <c:layout>
+        <c:manualLayout>
+          <c:layoutTarget val="inner"/>
+          <c:xMode val="edge"/>
+          <c:yMode val="edge"/>
+          <c:x val="5.6250000000000001E-2"/>
+          <c:y val="8.8281121537824719E-2"/>
+          <c:w val="0.84062499999999996"/>
+          <c:h val="0.82343775692435062"/>
+        </c:manualLayout>
+      </c:layout>
       <c:pie3DChart>
         <c:varyColors val="1"/>
         <c:ser>
@@ -1048,6 +1059,12 @@
           <c:dLbls>
             <c:dLbl>
               <c:idx val="0"/>
+              <c:layout>
+                <c:manualLayout>
+                  <c:x val="-7.8125000000000004E-4"/>
+                  <c:y val="-0.44531247260627022"/>
+                </c:manualLayout>
+              </c:layout>
               <c:spPr>
                 <a:noFill/>
                 <a:ln>
@@ -1487,6 +1504,17 @@
       </c:spPr>
     </c:backWall>
     <c:plotArea>
+      <c:layout>
+        <c:manualLayout>
+          <c:layoutTarget val="inner"/>
+          <c:xMode val="edge"/>
+          <c:yMode val="edge"/>
+          <c:x val="5.6250000000000001E-2"/>
+          <c:y val="8.8281121537824719E-2"/>
+          <c:w val="0.84062499999999996"/>
+          <c:h val="0.82343775692435062"/>
+        </c:manualLayout>
+      </c:layout>
       <c:pie3DChart>
         <c:varyColors val="1"/>
         <c:ser>
@@ -1606,6 +1634,12 @@
           <c:dLbls>
             <c:dLbl>
               <c:idx val="0"/>
+              <c:layout>
+                <c:manualLayout>
+                  <c:x val="-7.8125000000000004E-4"/>
+                  <c:y val="-0.44531247260627022"/>
+                </c:manualLayout>
+              </c:layout>
               <c:spPr>
                 <a:noFill/>
                 <a:ln>
@@ -2045,6 +2079,17 @@
       </c:spPr>
     </c:backWall>
     <c:plotArea>
+      <c:layout>
+        <c:manualLayout>
+          <c:layoutTarget val="inner"/>
+          <c:xMode val="edge"/>
+          <c:yMode val="edge"/>
+          <c:x val="5.6250000000000001E-2"/>
+          <c:y val="8.8281121537824719E-2"/>
+          <c:w val="0.84062499999999996"/>
+          <c:h val="0.82343775692435062"/>
+        </c:manualLayout>
+      </c:layout>
       <c:pie3DChart>
         <c:varyColors val="1"/>
         <c:ser>
@@ -2164,6 +2209,12 @@
           <c:dLbls>
             <c:dLbl>
               <c:idx val="0"/>
+              <c:layout>
+                <c:manualLayout>
+                  <c:x val="-7.8125000000000004E-4"/>
+                  <c:y val="-0.44531247260627022"/>
+                </c:manualLayout>
+              </c:layout>
               <c:spPr>
                 <a:noFill/>
                 <a:ln>
@@ -2603,6 +2654,17 @@
       </c:spPr>
     </c:backWall>
     <c:plotArea>
+      <c:layout>
+        <c:manualLayout>
+          <c:layoutTarget val="inner"/>
+          <c:xMode val="edge"/>
+          <c:yMode val="edge"/>
+          <c:x val="5.6250000000000001E-2"/>
+          <c:y val="8.8281121537824719E-2"/>
+          <c:w val="0.84062499999999996"/>
+          <c:h val="0.82343775692435062"/>
+        </c:manualLayout>
+      </c:layout>
       <c:pie3DChart>
         <c:varyColors val="1"/>
         <c:ser>
@@ -2722,6 +2784,12 @@
           <c:dLbls>
             <c:dLbl>
               <c:idx val="0"/>
+              <c:layout>
+                <c:manualLayout>
+                  <c:x val="-7.8125000000000004E-4"/>
+                  <c:y val="-0.44531247260627022"/>
+                </c:manualLayout>
+              </c:layout>
               <c:spPr>
                 <a:noFill/>
                 <a:ln>
@@ -3161,6 +3229,17 @@
       </c:spPr>
     </c:backWall>
     <c:plotArea>
+      <c:layout>
+        <c:manualLayout>
+          <c:layoutTarget val="inner"/>
+          <c:xMode val="edge"/>
+          <c:yMode val="edge"/>
+          <c:x val="5.3125307548469641E-2"/>
+          <c:y val="9.4597632547498256E-2"/>
+          <c:w val="0.84062499999999996"/>
+          <c:h val="0.82343775692435062"/>
+        </c:manualLayout>
+      </c:layout>
       <c:pie3DChart>
         <c:varyColors val="1"/>
         <c:ser>
@@ -3280,6 +3359,12 @@
           <c:dLbls>
             <c:dLbl>
               <c:idx val="0"/>
+              <c:layout>
+                <c:manualLayout>
+                  <c:x val="-0.22732149886822164"/>
+                  <c:y val="-0.35056475678901816"/>
+                </c:manualLayout>
+              </c:layout>
               <c:spPr>
                 <a:noFill/>
                 <a:ln>
@@ -3724,6 +3809,17 @@
       </c:spPr>
     </c:backWall>
     <c:plotArea>
+      <c:layout>
+        <c:manualLayout>
+          <c:layoutTarget val="inner"/>
+          <c:xMode val="edge"/>
+          <c:yMode val="edge"/>
+          <c:x val="5.6250000000000001E-2"/>
+          <c:y val="8.8281121537824719E-2"/>
+          <c:w val="0.84062499999999996"/>
+          <c:h val="0.82343775692435062"/>
+        </c:manualLayout>
+      </c:layout>
       <c:pie3DChart>
         <c:varyColors val="1"/>
         <c:ser>
@@ -3843,6 +3939,12 @@
           <c:dLbls>
             <c:dLbl>
               <c:idx val="0"/>
+              <c:layout>
+                <c:manualLayout>
+                  <c:x val="-7.8125000000000004E-4"/>
+                  <c:y val="-0.44531247260627022"/>
+                </c:manualLayout>
+              </c:layout>
               <c:spPr>
                 <a:noFill/>
                 <a:ln>
@@ -4282,6 +4384,17 @@
       </c:spPr>
     </c:backWall>
     <c:plotArea>
+      <c:layout>
+        <c:manualLayout>
+          <c:layoutTarget val="inner"/>
+          <c:xMode val="edge"/>
+          <c:yMode val="edge"/>
+          <c:x val="5.6250000000000001E-2"/>
+          <c:y val="8.8281121537824719E-2"/>
+          <c:w val="0.84062499999999996"/>
+          <c:h val="0.82343775692435062"/>
+        </c:manualLayout>
+      </c:layout>
       <c:pie3DChart>
         <c:varyColors val="1"/>
         <c:ser>
@@ -4401,6 +4514,12 @@
           <c:dLbls>
             <c:dLbl>
               <c:idx val="0"/>
+              <c:layout>
+                <c:manualLayout>
+                  <c:x val="-7.8125000000000004E-4"/>
+                  <c:y val="-0.44531247260627022"/>
+                </c:manualLayout>
+              </c:layout>
               <c:spPr>
                 <a:noFill/>
                 <a:ln>
@@ -4840,6 +4959,17 @@
       </c:spPr>
     </c:backWall>
     <c:plotArea>
+      <c:layout>
+        <c:manualLayout>
+          <c:layoutTarget val="inner"/>
+          <c:xMode val="edge"/>
+          <c:yMode val="edge"/>
+          <c:x val="5.6250000000000001E-2"/>
+          <c:y val="8.8281121537824719E-2"/>
+          <c:w val="0.84062499999999996"/>
+          <c:h val="0.82343775692435062"/>
+        </c:manualLayout>
+      </c:layout>
       <c:pie3DChart>
         <c:varyColors val="1"/>
         <c:ser>
@@ -4959,6 +5089,12 @@
           <c:dLbls>
             <c:dLbl>
               <c:idx val="0"/>
+              <c:layout>
+                <c:manualLayout>
+                  <c:x val="-7.8125000000000004E-4"/>
+                  <c:y val="-0.44531247260627022"/>
+                </c:manualLayout>
+              </c:layout>
               <c:spPr>
                 <a:noFill/>
                 <a:ln>
@@ -5398,6 +5534,17 @@
       </c:spPr>
     </c:backWall>
     <c:plotArea>
+      <c:layout>
+        <c:manualLayout>
+          <c:layoutTarget val="inner"/>
+          <c:xMode val="edge"/>
+          <c:yMode val="edge"/>
+          <c:x val="5.6250000000000001E-2"/>
+          <c:y val="8.8281121537824719E-2"/>
+          <c:w val="0.84062499999999996"/>
+          <c:h val="0.82343775692435062"/>
+        </c:manualLayout>
+      </c:layout>
       <c:pie3DChart>
         <c:varyColors val="1"/>
         <c:ser>
@@ -5517,6 +5664,12 @@
           <c:dLbls>
             <c:dLbl>
               <c:idx val="0"/>
+              <c:layout>
+                <c:manualLayout>
+                  <c:x val="-7.8125000000000004E-4"/>
+                  <c:y val="-0.44531247260627022"/>
+                </c:manualLayout>
+              </c:layout>
               <c:spPr>
                 <a:noFill/>
                 <a:ln>
@@ -5956,6 +6109,17 @@
       </c:spPr>
     </c:backWall>
     <c:plotArea>
+      <c:layout>
+        <c:manualLayout>
+          <c:layoutTarget val="inner"/>
+          <c:xMode val="edge"/>
+          <c:yMode val="edge"/>
+          <c:x val="5.6250000000000001E-2"/>
+          <c:y val="8.8281121537824719E-2"/>
+          <c:w val="0.84062499999999996"/>
+          <c:h val="0.82343775692435062"/>
+        </c:manualLayout>
+      </c:layout>
       <c:pie3DChart>
         <c:varyColors val="1"/>
         <c:ser>
@@ -6075,6 +6239,12 @@
           <c:dLbls>
             <c:dLbl>
               <c:idx val="0"/>
+              <c:layout>
+                <c:manualLayout>
+                  <c:x val="-7.8125000000000004E-4"/>
+                  <c:y val="-0.44531247260627022"/>
+                </c:manualLayout>
+              </c:layout>
               <c:spPr>
                 <a:noFill/>
                 <a:ln>

</xml_diff>

<commit_message>
fix(pptx): align chart4 dLbl idx=0 layout on uniform pattern
Sur 10 charts du template, 9 avaient un manualLayout idx=0 uniforme
(x=-0.0008, y=-0.4453) calibré pour centrer "N (P %)" au centre visuel
du pie 3D mono-cat 100%. Seul chart4 (Q4 "conditions d'accueil") avait
un layout idiosyncratique (x=-0.227, y=-0.3506) hérité du PDF EXEMPLE
original. Conséquence : label "5 (62 %)" sortait à gauche sur toute
formation Q4 dominée par "Très satisfait" — feedback Inès 14/05.

Patch ciblé chart4 uniquement, script idempotent versionné.

Co-Authored-By: Claude Opus 4.7 (1M context) <noreply@anthropic.com>
</commit_message>
<xml_diff>
--- a/templates/analysis-block.pptx
+++ b/templates/analysis-block.pptx
@@ -3361,8 +3361,8 @@
               <c:idx val="0"/>
               <c:layout>
                 <c:manualLayout>
-                  <c:x val="-0.22732149886822164"/>
-                  <c:y val="-0.35056475678901816"/>
+                  <c:x val="-7.8125000000000004E-4"/>
+                  <c:y val="-0.44531247260627022"/>
                 </c:manualLayout>
               </c:layout>
               <c:spPr>

</xml_diff>

<commit_message>
fix(pptx): align chart4 plotArea on uniform pattern (v2.4.2)
3e idiosyncrasie de chart4 héritée du PDF EXEMPLE original : plotArea
positionné à (x=0.05313, y=0.09460) vs (x=0.05625, y=0.08828) sur les
9 autres charts.

Conséquence : le disque 3D entier de chart4 était décalé ~0.7 mm à
gauche et ~0.8 mm plus bas que les autres. Le label, qui suit le
centroid, héritait du décalage. Visible quand on défile Q1-Q10
(feedback Guillaume 14/05).

Patch aligne chart4 plotArea sur les valeurs uniformes des 9 autres.
Idempotent comme les patches précédents (idx=0 dLbl, chart_size, etc.).

Co-Authored-By: Claude Opus 4.7 (1M context) <noreply@anthropic.com>
</commit_message>
<xml_diff>
--- a/templates/analysis-block.pptx
+++ b/templates/analysis-block.pptx
@@ -3234,8 +3234,8 @@
           <c:layoutTarget val="inner"/>
           <c:xMode val="edge"/>
           <c:yMode val="edge"/>
-          <c:x val="5.3125307548469641E-2"/>
-          <c:y val="9.4597632547498256E-2"/>
+          <c:x val="5.6250000000000001E-2"/>
+          <c:y val="8.8281121537824719E-2"/>
           <c:w val="0.84062499999999996"/>
           <c:h val="0.82343775692435062"/>
         </c:manualLayout>

</xml_diff>

<commit_message>
fix(pptx): align dPt borders/contours on slice fills (v2.4.3)
Dans les 10 charts du template, dPt idx=0 (slice verte "Très satisfait")
a sa bordure <a:ln> et son contour 3D <a:sp3d>/<a:contourClr> alignés
sur le fill (srgb=00B050). Tous les autres dPt (idx=1 jaune, idx=2
orange, idx=3 rouge + 2e série fantôme accent1/2/3/4) avaient ln +
contourClr en schemeClr lt1 (blanc) — héritage du PDF EXEMPLE Pic.

Conséquence : quand une slice non-idx=0 apparaît (cas multi-cat genre
Q1 jaune 1/17%), liseré blanc autour de la slice + micro cercle blanc
visible aux sommets 3D (effet contourW=2pt blanc sur fond coloré).

Patch aligne ln/solidFill et sp3d/contourClr sur le fill de chaque dPt
→ bordures et contours invisibles. Pattern uniforme avec ce que Pic
avait fait nativement sur idx=0.

140 refs alignées (14 par chart × 10 charts). Idempotent.

Co-Authored-By: Claude Opus 4.7 (1M context) <noreply@anthropic.com>
</commit_message>
<xml_diff>
--- a/templates/analysis-block.pptx
+++ b/templates/analysis-block.pptx
@@ -990,13 +990,13 @@
               </a:solidFill>
               <a:ln w="25400">
                 <a:solidFill>
-                  <a:schemeClr val="lt1"/>
+                  <a:srgbClr val="FFFF00"/>
                 </a:solidFill>
               </a:ln>
               <a:effectLst/>
               <a:sp3d contourW="25400">
                 <a:contourClr>
-                  <a:schemeClr val="lt1"/>
+                  <a:srgbClr val="FFFF00"/>
                 </a:contourClr>
               </a:sp3d>
             </c:spPr>
@@ -1015,13 +1015,13 @@
               </a:solidFill>
               <a:ln w="25400">
                 <a:solidFill>
-                  <a:schemeClr val="lt1"/>
+                  <a:srgbClr val="FFC000"/>
                 </a:solidFill>
               </a:ln>
               <a:effectLst/>
               <a:sp3d contourW="25400">
                 <a:contourClr>
-                  <a:schemeClr val="lt1"/>
+                  <a:srgbClr val="FFC000"/>
                 </a:contourClr>
               </a:sp3d>
             </c:spPr>
@@ -1040,13 +1040,13 @@
               </a:solidFill>
               <a:ln w="25400">
                 <a:solidFill>
-                  <a:schemeClr val="lt1"/>
+                  <a:srgbClr val="FF0000"/>
                 </a:solidFill>
               </a:ln>
               <a:effectLst/>
               <a:sp3d contourW="25400">
                 <a:contourClr>
-                  <a:schemeClr val="lt1"/>
+                  <a:srgbClr val="FF0000"/>
                 </a:contourClr>
               </a:sp3d>
             </c:spPr>
@@ -1259,13 +1259,13 @@
               </a:solidFill>
               <a:ln w="25400">
                 <a:solidFill>
-                  <a:schemeClr val="lt1"/>
+                  <a:schemeClr val="accent1"/>
                 </a:solidFill>
               </a:ln>
               <a:effectLst/>
               <a:sp3d contourW="25400">
                 <a:contourClr>
-                  <a:schemeClr val="lt1"/>
+                  <a:schemeClr val="accent1"/>
                 </a:contourClr>
               </a:sp3d>
             </c:spPr>
@@ -1284,13 +1284,13 @@
               </a:solidFill>
               <a:ln w="25400">
                 <a:solidFill>
-                  <a:schemeClr val="lt1"/>
+                  <a:schemeClr val="accent2"/>
                 </a:solidFill>
               </a:ln>
               <a:effectLst/>
               <a:sp3d contourW="25400">
                 <a:contourClr>
-                  <a:schemeClr val="lt1"/>
+                  <a:schemeClr val="accent2"/>
                 </a:contourClr>
               </a:sp3d>
             </c:spPr>
@@ -1309,13 +1309,13 @@
               </a:solidFill>
               <a:ln w="25400">
                 <a:solidFill>
-                  <a:schemeClr val="lt1"/>
+                  <a:schemeClr val="accent3"/>
                 </a:solidFill>
               </a:ln>
               <a:effectLst/>
               <a:sp3d contourW="25400">
                 <a:contourClr>
-                  <a:schemeClr val="lt1"/>
+                  <a:schemeClr val="accent3"/>
                 </a:contourClr>
               </a:sp3d>
             </c:spPr>
@@ -1334,13 +1334,13 @@
               </a:solidFill>
               <a:ln w="25400">
                 <a:solidFill>
-                  <a:schemeClr val="lt1"/>
+                  <a:schemeClr val="accent4"/>
                 </a:solidFill>
               </a:ln>
               <a:effectLst/>
               <a:sp3d contourW="25400">
                 <a:contourClr>
-                  <a:schemeClr val="lt1"/>
+                  <a:schemeClr val="accent4"/>
                 </a:contourClr>
               </a:sp3d>
             </c:spPr>
@@ -1565,13 +1565,13 @@
               </a:solidFill>
               <a:ln w="25400">
                 <a:solidFill>
-                  <a:schemeClr val="lt1"/>
+                  <a:srgbClr val="FFFF00"/>
                 </a:solidFill>
               </a:ln>
               <a:effectLst/>
               <a:sp3d contourW="25400">
                 <a:contourClr>
-                  <a:schemeClr val="lt1"/>
+                  <a:srgbClr val="FFFF00"/>
                 </a:contourClr>
               </a:sp3d>
             </c:spPr>
@@ -1590,13 +1590,13 @@
               </a:solidFill>
               <a:ln w="25400">
                 <a:solidFill>
-                  <a:schemeClr val="lt1"/>
+                  <a:srgbClr val="FFC000"/>
                 </a:solidFill>
               </a:ln>
               <a:effectLst/>
               <a:sp3d contourW="25400">
                 <a:contourClr>
-                  <a:schemeClr val="lt1"/>
+                  <a:srgbClr val="FFC000"/>
                 </a:contourClr>
               </a:sp3d>
             </c:spPr>
@@ -1615,13 +1615,13 @@
               </a:solidFill>
               <a:ln w="25400">
                 <a:solidFill>
-                  <a:schemeClr val="lt1"/>
+                  <a:srgbClr val="FF0000"/>
                 </a:solidFill>
               </a:ln>
               <a:effectLst/>
               <a:sp3d contourW="25400">
                 <a:contourClr>
-                  <a:schemeClr val="lt1"/>
+                  <a:srgbClr val="FF0000"/>
                 </a:contourClr>
               </a:sp3d>
             </c:spPr>
@@ -1834,13 +1834,13 @@
               </a:solidFill>
               <a:ln w="25400">
                 <a:solidFill>
-                  <a:schemeClr val="lt1"/>
+                  <a:schemeClr val="accent1"/>
                 </a:solidFill>
               </a:ln>
               <a:effectLst/>
               <a:sp3d contourW="25400">
                 <a:contourClr>
-                  <a:schemeClr val="lt1"/>
+                  <a:schemeClr val="accent1"/>
                 </a:contourClr>
               </a:sp3d>
             </c:spPr>
@@ -1859,13 +1859,13 @@
               </a:solidFill>
               <a:ln w="25400">
                 <a:solidFill>
-                  <a:schemeClr val="lt1"/>
+                  <a:schemeClr val="accent2"/>
                 </a:solidFill>
               </a:ln>
               <a:effectLst/>
               <a:sp3d contourW="25400">
                 <a:contourClr>
-                  <a:schemeClr val="lt1"/>
+                  <a:schemeClr val="accent2"/>
                 </a:contourClr>
               </a:sp3d>
             </c:spPr>
@@ -1884,13 +1884,13 @@
               </a:solidFill>
               <a:ln w="25400">
                 <a:solidFill>
-                  <a:schemeClr val="lt1"/>
+                  <a:schemeClr val="accent3"/>
                 </a:solidFill>
               </a:ln>
               <a:effectLst/>
               <a:sp3d contourW="25400">
                 <a:contourClr>
-                  <a:schemeClr val="lt1"/>
+                  <a:schemeClr val="accent3"/>
                 </a:contourClr>
               </a:sp3d>
             </c:spPr>
@@ -1909,13 +1909,13 @@
               </a:solidFill>
               <a:ln w="25400">
                 <a:solidFill>
-                  <a:schemeClr val="lt1"/>
+                  <a:schemeClr val="accent4"/>
                 </a:solidFill>
               </a:ln>
               <a:effectLst/>
               <a:sp3d contourW="25400">
                 <a:contourClr>
-                  <a:schemeClr val="lt1"/>
+                  <a:schemeClr val="accent4"/>
                 </a:contourClr>
               </a:sp3d>
             </c:spPr>
@@ -2140,13 +2140,13 @@
               </a:solidFill>
               <a:ln w="25400">
                 <a:solidFill>
-                  <a:schemeClr val="lt1"/>
+                  <a:srgbClr val="FFFF00"/>
                 </a:solidFill>
               </a:ln>
               <a:effectLst/>
               <a:sp3d contourW="25400">
                 <a:contourClr>
-                  <a:schemeClr val="lt1"/>
+                  <a:srgbClr val="FFFF00"/>
                 </a:contourClr>
               </a:sp3d>
             </c:spPr>
@@ -2165,13 +2165,13 @@
               </a:solidFill>
               <a:ln w="25400">
                 <a:solidFill>
-                  <a:schemeClr val="lt1"/>
+                  <a:srgbClr val="FFC000"/>
                 </a:solidFill>
               </a:ln>
               <a:effectLst/>
               <a:sp3d contourW="25400">
                 <a:contourClr>
-                  <a:schemeClr val="lt1"/>
+                  <a:srgbClr val="FFC000"/>
                 </a:contourClr>
               </a:sp3d>
             </c:spPr>
@@ -2190,13 +2190,13 @@
               </a:solidFill>
               <a:ln w="25400">
                 <a:solidFill>
-                  <a:schemeClr val="lt1"/>
+                  <a:srgbClr val="FF0000"/>
                 </a:solidFill>
               </a:ln>
               <a:effectLst/>
               <a:sp3d contourW="25400">
                 <a:contourClr>
-                  <a:schemeClr val="lt1"/>
+                  <a:srgbClr val="FF0000"/>
                 </a:contourClr>
               </a:sp3d>
             </c:spPr>
@@ -2409,13 +2409,13 @@
               </a:solidFill>
               <a:ln w="25400">
                 <a:solidFill>
-                  <a:schemeClr val="lt1"/>
+                  <a:schemeClr val="accent1"/>
                 </a:solidFill>
               </a:ln>
               <a:effectLst/>
               <a:sp3d contourW="25400">
                 <a:contourClr>
-                  <a:schemeClr val="lt1"/>
+                  <a:schemeClr val="accent1"/>
                 </a:contourClr>
               </a:sp3d>
             </c:spPr>
@@ -2434,13 +2434,13 @@
               </a:solidFill>
               <a:ln w="25400">
                 <a:solidFill>
-                  <a:schemeClr val="lt1"/>
+                  <a:schemeClr val="accent2"/>
                 </a:solidFill>
               </a:ln>
               <a:effectLst/>
               <a:sp3d contourW="25400">
                 <a:contourClr>
-                  <a:schemeClr val="lt1"/>
+                  <a:schemeClr val="accent2"/>
                 </a:contourClr>
               </a:sp3d>
             </c:spPr>
@@ -2459,13 +2459,13 @@
               </a:solidFill>
               <a:ln w="25400">
                 <a:solidFill>
-                  <a:schemeClr val="lt1"/>
+                  <a:schemeClr val="accent3"/>
                 </a:solidFill>
               </a:ln>
               <a:effectLst/>
               <a:sp3d contourW="25400">
                 <a:contourClr>
-                  <a:schemeClr val="lt1"/>
+                  <a:schemeClr val="accent3"/>
                 </a:contourClr>
               </a:sp3d>
             </c:spPr>
@@ -2484,13 +2484,13 @@
               </a:solidFill>
               <a:ln w="25400">
                 <a:solidFill>
-                  <a:schemeClr val="lt1"/>
+                  <a:schemeClr val="accent4"/>
                 </a:solidFill>
               </a:ln>
               <a:effectLst/>
               <a:sp3d contourW="25400">
                 <a:contourClr>
-                  <a:schemeClr val="lt1"/>
+                  <a:schemeClr val="accent4"/>
                 </a:contourClr>
               </a:sp3d>
             </c:spPr>
@@ -2715,13 +2715,13 @@
               </a:solidFill>
               <a:ln w="25400">
                 <a:solidFill>
-                  <a:schemeClr val="lt1"/>
+                  <a:srgbClr val="FFFF00"/>
                 </a:solidFill>
               </a:ln>
               <a:effectLst/>
               <a:sp3d contourW="25400">
                 <a:contourClr>
-                  <a:schemeClr val="lt1"/>
+                  <a:srgbClr val="FFFF00"/>
                 </a:contourClr>
               </a:sp3d>
             </c:spPr>
@@ -2740,13 +2740,13 @@
               </a:solidFill>
               <a:ln w="25400">
                 <a:solidFill>
-                  <a:schemeClr val="lt1"/>
+                  <a:srgbClr val="FFC000"/>
                 </a:solidFill>
               </a:ln>
               <a:effectLst/>
               <a:sp3d contourW="25400">
                 <a:contourClr>
-                  <a:schemeClr val="lt1"/>
+                  <a:srgbClr val="FFC000"/>
                 </a:contourClr>
               </a:sp3d>
             </c:spPr>
@@ -2765,13 +2765,13 @@
               </a:solidFill>
               <a:ln w="25400">
                 <a:solidFill>
-                  <a:schemeClr val="lt1"/>
+                  <a:srgbClr val="FF0000"/>
                 </a:solidFill>
               </a:ln>
               <a:effectLst/>
               <a:sp3d contourW="25400">
                 <a:contourClr>
-                  <a:schemeClr val="lt1"/>
+                  <a:srgbClr val="FF0000"/>
                 </a:contourClr>
               </a:sp3d>
             </c:spPr>
@@ -2984,13 +2984,13 @@
               </a:solidFill>
               <a:ln w="25400">
                 <a:solidFill>
-                  <a:schemeClr val="lt1"/>
+                  <a:schemeClr val="accent1"/>
                 </a:solidFill>
               </a:ln>
               <a:effectLst/>
               <a:sp3d contourW="25400">
                 <a:contourClr>
-                  <a:schemeClr val="lt1"/>
+                  <a:schemeClr val="accent1"/>
                 </a:contourClr>
               </a:sp3d>
             </c:spPr>
@@ -3009,13 +3009,13 @@
               </a:solidFill>
               <a:ln w="25400">
                 <a:solidFill>
-                  <a:schemeClr val="lt1"/>
+                  <a:schemeClr val="accent2"/>
                 </a:solidFill>
               </a:ln>
               <a:effectLst/>
               <a:sp3d contourW="25400">
                 <a:contourClr>
-                  <a:schemeClr val="lt1"/>
+                  <a:schemeClr val="accent2"/>
                 </a:contourClr>
               </a:sp3d>
             </c:spPr>
@@ -3034,13 +3034,13 @@
               </a:solidFill>
               <a:ln w="25400">
                 <a:solidFill>
-                  <a:schemeClr val="lt1"/>
+                  <a:schemeClr val="accent3"/>
                 </a:solidFill>
               </a:ln>
               <a:effectLst/>
               <a:sp3d contourW="25400">
                 <a:contourClr>
-                  <a:schemeClr val="lt1"/>
+                  <a:schemeClr val="accent3"/>
                 </a:contourClr>
               </a:sp3d>
             </c:spPr>
@@ -3059,13 +3059,13 @@
               </a:solidFill>
               <a:ln w="25400">
                 <a:solidFill>
-                  <a:schemeClr val="lt1"/>
+                  <a:schemeClr val="accent4"/>
                 </a:solidFill>
               </a:ln>
               <a:effectLst/>
               <a:sp3d contourW="25400">
                 <a:contourClr>
-                  <a:schemeClr val="lt1"/>
+                  <a:schemeClr val="accent4"/>
                 </a:contourClr>
               </a:sp3d>
             </c:spPr>
@@ -3290,13 +3290,13 @@
               </a:solidFill>
               <a:ln w="25400">
                 <a:solidFill>
-                  <a:schemeClr val="lt1"/>
+                  <a:srgbClr val="FFFF00"/>
                 </a:solidFill>
               </a:ln>
               <a:effectLst/>
               <a:sp3d contourW="25400">
                 <a:contourClr>
-                  <a:schemeClr val="lt1"/>
+                  <a:srgbClr val="FFFF00"/>
                 </a:contourClr>
               </a:sp3d>
             </c:spPr>
@@ -3315,13 +3315,13 @@
               </a:solidFill>
               <a:ln w="25400">
                 <a:solidFill>
-                  <a:schemeClr val="lt1"/>
+                  <a:srgbClr val="FFC000"/>
                 </a:solidFill>
               </a:ln>
               <a:effectLst/>
               <a:sp3d contourW="25400">
                 <a:contourClr>
-                  <a:schemeClr val="lt1"/>
+                  <a:srgbClr val="FFC000"/>
                 </a:contourClr>
               </a:sp3d>
             </c:spPr>
@@ -3340,13 +3340,13 @@
               </a:solidFill>
               <a:ln w="25400">
                 <a:solidFill>
-                  <a:schemeClr val="lt1"/>
+                  <a:srgbClr val="FF0000"/>
                 </a:solidFill>
               </a:ln>
               <a:effectLst/>
               <a:sp3d contourW="25400">
                 <a:contourClr>
-                  <a:schemeClr val="lt1"/>
+                  <a:srgbClr val="FF0000"/>
                 </a:contourClr>
               </a:sp3d>
             </c:spPr>
@@ -3564,13 +3564,13 @@
               </a:solidFill>
               <a:ln w="25400">
                 <a:solidFill>
-                  <a:schemeClr val="lt1"/>
+                  <a:schemeClr val="accent1"/>
                 </a:solidFill>
               </a:ln>
               <a:effectLst/>
               <a:sp3d contourW="25400">
                 <a:contourClr>
-                  <a:schemeClr val="lt1"/>
+                  <a:schemeClr val="accent1"/>
                 </a:contourClr>
               </a:sp3d>
             </c:spPr>
@@ -3589,13 +3589,13 @@
               </a:solidFill>
               <a:ln w="25400">
                 <a:solidFill>
-                  <a:schemeClr val="lt1"/>
+                  <a:schemeClr val="accent2"/>
                 </a:solidFill>
               </a:ln>
               <a:effectLst/>
               <a:sp3d contourW="25400">
                 <a:contourClr>
-                  <a:schemeClr val="lt1"/>
+                  <a:schemeClr val="accent2"/>
                 </a:contourClr>
               </a:sp3d>
             </c:spPr>
@@ -3614,13 +3614,13 @@
               </a:solidFill>
               <a:ln w="25400">
                 <a:solidFill>
-                  <a:schemeClr val="lt1"/>
+                  <a:schemeClr val="accent3"/>
                 </a:solidFill>
               </a:ln>
               <a:effectLst/>
               <a:sp3d contourW="25400">
                 <a:contourClr>
-                  <a:schemeClr val="lt1"/>
+                  <a:schemeClr val="accent3"/>
                 </a:contourClr>
               </a:sp3d>
             </c:spPr>
@@ -3639,13 +3639,13 @@
               </a:solidFill>
               <a:ln w="25400">
                 <a:solidFill>
-                  <a:schemeClr val="lt1"/>
+                  <a:schemeClr val="accent4"/>
                 </a:solidFill>
               </a:ln>
               <a:effectLst/>
               <a:sp3d contourW="25400">
                 <a:contourClr>
-                  <a:schemeClr val="lt1"/>
+                  <a:schemeClr val="accent4"/>
                 </a:contourClr>
               </a:sp3d>
             </c:spPr>
@@ -3870,13 +3870,13 @@
               </a:solidFill>
               <a:ln w="25400">
                 <a:solidFill>
-                  <a:schemeClr val="lt1"/>
+                  <a:srgbClr val="FFFF00"/>
                 </a:solidFill>
               </a:ln>
               <a:effectLst/>
               <a:sp3d contourW="25400">
                 <a:contourClr>
-                  <a:schemeClr val="lt1"/>
+                  <a:srgbClr val="FFFF00"/>
                 </a:contourClr>
               </a:sp3d>
             </c:spPr>
@@ -3895,13 +3895,13 @@
               </a:solidFill>
               <a:ln w="25400">
                 <a:solidFill>
-                  <a:schemeClr val="lt1"/>
+                  <a:srgbClr val="FFC000"/>
                 </a:solidFill>
               </a:ln>
               <a:effectLst/>
               <a:sp3d contourW="25400">
                 <a:contourClr>
-                  <a:schemeClr val="lt1"/>
+                  <a:srgbClr val="FFC000"/>
                 </a:contourClr>
               </a:sp3d>
             </c:spPr>
@@ -3920,13 +3920,13 @@
               </a:solidFill>
               <a:ln w="25400">
                 <a:solidFill>
-                  <a:schemeClr val="lt1"/>
+                  <a:srgbClr val="FF0000"/>
                 </a:solidFill>
               </a:ln>
               <a:effectLst/>
               <a:sp3d contourW="25400">
                 <a:contourClr>
-                  <a:schemeClr val="lt1"/>
+                  <a:srgbClr val="FF0000"/>
                 </a:contourClr>
               </a:sp3d>
             </c:spPr>
@@ -4139,13 +4139,13 @@
               </a:solidFill>
               <a:ln w="25400">
                 <a:solidFill>
-                  <a:schemeClr val="lt1"/>
+                  <a:schemeClr val="accent1"/>
                 </a:solidFill>
               </a:ln>
               <a:effectLst/>
               <a:sp3d contourW="25400">
                 <a:contourClr>
-                  <a:schemeClr val="lt1"/>
+                  <a:schemeClr val="accent1"/>
                 </a:contourClr>
               </a:sp3d>
             </c:spPr>
@@ -4164,13 +4164,13 @@
               </a:solidFill>
               <a:ln w="25400">
                 <a:solidFill>
-                  <a:schemeClr val="lt1"/>
+                  <a:schemeClr val="accent2"/>
                 </a:solidFill>
               </a:ln>
               <a:effectLst/>
               <a:sp3d contourW="25400">
                 <a:contourClr>
-                  <a:schemeClr val="lt1"/>
+                  <a:schemeClr val="accent2"/>
                 </a:contourClr>
               </a:sp3d>
             </c:spPr>
@@ -4189,13 +4189,13 @@
               </a:solidFill>
               <a:ln w="25400">
                 <a:solidFill>
-                  <a:schemeClr val="lt1"/>
+                  <a:schemeClr val="accent3"/>
                 </a:solidFill>
               </a:ln>
               <a:effectLst/>
               <a:sp3d contourW="25400">
                 <a:contourClr>
-                  <a:schemeClr val="lt1"/>
+                  <a:schemeClr val="accent3"/>
                 </a:contourClr>
               </a:sp3d>
             </c:spPr>
@@ -4214,13 +4214,13 @@
               </a:solidFill>
               <a:ln w="25400">
                 <a:solidFill>
-                  <a:schemeClr val="lt1"/>
+                  <a:schemeClr val="accent4"/>
                 </a:solidFill>
               </a:ln>
               <a:effectLst/>
               <a:sp3d contourW="25400">
                 <a:contourClr>
-                  <a:schemeClr val="lt1"/>
+                  <a:schemeClr val="accent4"/>
                 </a:contourClr>
               </a:sp3d>
             </c:spPr>
@@ -4445,13 +4445,13 @@
               </a:solidFill>
               <a:ln w="25400">
                 <a:solidFill>
-                  <a:schemeClr val="lt1"/>
+                  <a:srgbClr val="FFFF00"/>
                 </a:solidFill>
               </a:ln>
               <a:effectLst/>
               <a:sp3d contourW="25400">
                 <a:contourClr>
-                  <a:schemeClr val="lt1"/>
+                  <a:srgbClr val="FFFF00"/>
                 </a:contourClr>
               </a:sp3d>
             </c:spPr>
@@ -4470,13 +4470,13 @@
               </a:solidFill>
               <a:ln w="25400">
                 <a:solidFill>
-                  <a:schemeClr val="lt1"/>
+                  <a:srgbClr val="FFC000"/>
                 </a:solidFill>
               </a:ln>
               <a:effectLst/>
               <a:sp3d contourW="25400">
                 <a:contourClr>
-                  <a:schemeClr val="lt1"/>
+                  <a:srgbClr val="FFC000"/>
                 </a:contourClr>
               </a:sp3d>
             </c:spPr>
@@ -4495,13 +4495,13 @@
               </a:solidFill>
               <a:ln w="25400">
                 <a:solidFill>
-                  <a:schemeClr val="lt1"/>
+                  <a:srgbClr val="FF0000"/>
                 </a:solidFill>
               </a:ln>
               <a:effectLst/>
               <a:sp3d contourW="25400">
                 <a:contourClr>
-                  <a:schemeClr val="lt1"/>
+                  <a:srgbClr val="FF0000"/>
                 </a:contourClr>
               </a:sp3d>
             </c:spPr>
@@ -4714,13 +4714,13 @@
               </a:solidFill>
               <a:ln w="25400">
                 <a:solidFill>
-                  <a:schemeClr val="lt1"/>
+                  <a:schemeClr val="accent1"/>
                 </a:solidFill>
               </a:ln>
               <a:effectLst/>
               <a:sp3d contourW="25400">
                 <a:contourClr>
-                  <a:schemeClr val="lt1"/>
+                  <a:schemeClr val="accent1"/>
                 </a:contourClr>
               </a:sp3d>
             </c:spPr>
@@ -4739,13 +4739,13 @@
               </a:solidFill>
               <a:ln w="25400">
                 <a:solidFill>
-                  <a:schemeClr val="lt1"/>
+                  <a:schemeClr val="accent2"/>
                 </a:solidFill>
               </a:ln>
               <a:effectLst/>
               <a:sp3d contourW="25400">
                 <a:contourClr>
-                  <a:schemeClr val="lt1"/>
+                  <a:schemeClr val="accent2"/>
                 </a:contourClr>
               </a:sp3d>
             </c:spPr>
@@ -4764,13 +4764,13 @@
               </a:solidFill>
               <a:ln w="25400">
                 <a:solidFill>
-                  <a:schemeClr val="lt1"/>
+                  <a:schemeClr val="accent3"/>
                 </a:solidFill>
               </a:ln>
               <a:effectLst/>
               <a:sp3d contourW="25400">
                 <a:contourClr>
-                  <a:schemeClr val="lt1"/>
+                  <a:schemeClr val="accent3"/>
                 </a:contourClr>
               </a:sp3d>
             </c:spPr>
@@ -4789,13 +4789,13 @@
               </a:solidFill>
               <a:ln w="25400">
                 <a:solidFill>
-                  <a:schemeClr val="lt1"/>
+                  <a:schemeClr val="accent4"/>
                 </a:solidFill>
               </a:ln>
               <a:effectLst/>
               <a:sp3d contourW="25400">
                 <a:contourClr>
-                  <a:schemeClr val="lt1"/>
+                  <a:schemeClr val="accent4"/>
                 </a:contourClr>
               </a:sp3d>
             </c:spPr>
@@ -5020,13 +5020,13 @@
               </a:solidFill>
               <a:ln w="25400">
                 <a:solidFill>
-                  <a:schemeClr val="lt1"/>
+                  <a:srgbClr val="FFFF00"/>
                 </a:solidFill>
               </a:ln>
               <a:effectLst/>
               <a:sp3d contourW="25400">
                 <a:contourClr>
-                  <a:schemeClr val="lt1"/>
+                  <a:srgbClr val="FFFF00"/>
                 </a:contourClr>
               </a:sp3d>
             </c:spPr>
@@ -5045,13 +5045,13 @@
               </a:solidFill>
               <a:ln w="25400">
                 <a:solidFill>
-                  <a:schemeClr val="lt1"/>
+                  <a:srgbClr val="FFC000"/>
                 </a:solidFill>
               </a:ln>
               <a:effectLst/>
               <a:sp3d contourW="25400">
                 <a:contourClr>
-                  <a:schemeClr val="lt1"/>
+                  <a:srgbClr val="FFC000"/>
                 </a:contourClr>
               </a:sp3d>
             </c:spPr>
@@ -5070,13 +5070,13 @@
               </a:solidFill>
               <a:ln w="25400">
                 <a:solidFill>
-                  <a:schemeClr val="lt1"/>
+                  <a:srgbClr val="FF0000"/>
                 </a:solidFill>
               </a:ln>
               <a:effectLst/>
               <a:sp3d contourW="25400">
                 <a:contourClr>
-                  <a:schemeClr val="lt1"/>
+                  <a:srgbClr val="FF0000"/>
                 </a:contourClr>
               </a:sp3d>
             </c:spPr>
@@ -5289,13 +5289,13 @@
               </a:solidFill>
               <a:ln w="25400">
                 <a:solidFill>
-                  <a:schemeClr val="lt1"/>
+                  <a:schemeClr val="accent1"/>
                 </a:solidFill>
               </a:ln>
               <a:effectLst/>
               <a:sp3d contourW="25400">
                 <a:contourClr>
-                  <a:schemeClr val="lt1"/>
+                  <a:schemeClr val="accent1"/>
                 </a:contourClr>
               </a:sp3d>
             </c:spPr>
@@ -5314,13 +5314,13 @@
               </a:solidFill>
               <a:ln w="25400">
                 <a:solidFill>
-                  <a:schemeClr val="lt1"/>
+                  <a:schemeClr val="accent2"/>
                 </a:solidFill>
               </a:ln>
               <a:effectLst/>
               <a:sp3d contourW="25400">
                 <a:contourClr>
-                  <a:schemeClr val="lt1"/>
+                  <a:schemeClr val="accent2"/>
                 </a:contourClr>
               </a:sp3d>
             </c:spPr>
@@ -5339,13 +5339,13 @@
               </a:solidFill>
               <a:ln w="25400">
                 <a:solidFill>
-                  <a:schemeClr val="lt1"/>
+                  <a:schemeClr val="accent3"/>
                 </a:solidFill>
               </a:ln>
               <a:effectLst/>
               <a:sp3d contourW="25400">
                 <a:contourClr>
-                  <a:schemeClr val="lt1"/>
+                  <a:schemeClr val="accent3"/>
                 </a:contourClr>
               </a:sp3d>
             </c:spPr>
@@ -5364,13 +5364,13 @@
               </a:solidFill>
               <a:ln w="25400">
                 <a:solidFill>
-                  <a:schemeClr val="lt1"/>
+                  <a:schemeClr val="accent4"/>
                 </a:solidFill>
               </a:ln>
               <a:effectLst/>
               <a:sp3d contourW="25400">
                 <a:contourClr>
-                  <a:schemeClr val="lt1"/>
+                  <a:schemeClr val="accent4"/>
                 </a:contourClr>
               </a:sp3d>
             </c:spPr>
@@ -5595,13 +5595,13 @@
               </a:solidFill>
               <a:ln w="25400">
                 <a:solidFill>
-                  <a:schemeClr val="lt1"/>
+                  <a:srgbClr val="FFFF00"/>
                 </a:solidFill>
               </a:ln>
               <a:effectLst/>
               <a:sp3d contourW="25400">
                 <a:contourClr>
-                  <a:schemeClr val="lt1"/>
+                  <a:srgbClr val="FFFF00"/>
                 </a:contourClr>
               </a:sp3d>
             </c:spPr>
@@ -5620,13 +5620,13 @@
               </a:solidFill>
               <a:ln w="25400">
                 <a:solidFill>
-                  <a:schemeClr val="lt1"/>
+                  <a:srgbClr val="FFC000"/>
                 </a:solidFill>
               </a:ln>
               <a:effectLst/>
               <a:sp3d contourW="25400">
                 <a:contourClr>
-                  <a:schemeClr val="lt1"/>
+                  <a:srgbClr val="FFC000"/>
                 </a:contourClr>
               </a:sp3d>
             </c:spPr>
@@ -5645,13 +5645,13 @@
               </a:solidFill>
               <a:ln w="25400">
                 <a:solidFill>
-                  <a:schemeClr val="lt1"/>
+                  <a:srgbClr val="FF0000"/>
                 </a:solidFill>
               </a:ln>
               <a:effectLst/>
               <a:sp3d contourW="25400">
                 <a:contourClr>
-                  <a:schemeClr val="lt1"/>
+                  <a:srgbClr val="FF0000"/>
                 </a:contourClr>
               </a:sp3d>
             </c:spPr>
@@ -5864,13 +5864,13 @@
               </a:solidFill>
               <a:ln w="25400">
                 <a:solidFill>
-                  <a:schemeClr val="lt1"/>
+                  <a:schemeClr val="accent1"/>
                 </a:solidFill>
               </a:ln>
               <a:effectLst/>
               <a:sp3d contourW="25400">
                 <a:contourClr>
-                  <a:schemeClr val="lt1"/>
+                  <a:schemeClr val="accent1"/>
                 </a:contourClr>
               </a:sp3d>
             </c:spPr>
@@ -5889,13 +5889,13 @@
               </a:solidFill>
               <a:ln w="25400">
                 <a:solidFill>
-                  <a:schemeClr val="lt1"/>
+                  <a:schemeClr val="accent2"/>
                 </a:solidFill>
               </a:ln>
               <a:effectLst/>
               <a:sp3d contourW="25400">
                 <a:contourClr>
-                  <a:schemeClr val="lt1"/>
+                  <a:schemeClr val="accent2"/>
                 </a:contourClr>
               </a:sp3d>
             </c:spPr>
@@ -5914,13 +5914,13 @@
               </a:solidFill>
               <a:ln w="25400">
                 <a:solidFill>
-                  <a:schemeClr val="lt1"/>
+                  <a:schemeClr val="accent3"/>
                 </a:solidFill>
               </a:ln>
               <a:effectLst/>
               <a:sp3d contourW="25400">
                 <a:contourClr>
-                  <a:schemeClr val="lt1"/>
+                  <a:schemeClr val="accent3"/>
                 </a:contourClr>
               </a:sp3d>
             </c:spPr>
@@ -5939,13 +5939,13 @@
               </a:solidFill>
               <a:ln w="25400">
                 <a:solidFill>
-                  <a:schemeClr val="lt1"/>
+                  <a:schemeClr val="accent4"/>
                 </a:solidFill>
               </a:ln>
               <a:effectLst/>
               <a:sp3d contourW="25400">
                 <a:contourClr>
-                  <a:schemeClr val="lt1"/>
+                  <a:schemeClr val="accent4"/>
                 </a:contourClr>
               </a:sp3d>
             </c:spPr>
@@ -6170,13 +6170,13 @@
               </a:solidFill>
               <a:ln w="25400">
                 <a:solidFill>
-                  <a:schemeClr val="lt1"/>
+                  <a:srgbClr val="FFFF00"/>
                 </a:solidFill>
               </a:ln>
               <a:effectLst/>
               <a:sp3d contourW="25400">
                 <a:contourClr>
-                  <a:schemeClr val="lt1"/>
+                  <a:srgbClr val="FFFF00"/>
                 </a:contourClr>
               </a:sp3d>
             </c:spPr>
@@ -6195,13 +6195,13 @@
               </a:solidFill>
               <a:ln w="25400">
                 <a:solidFill>
-                  <a:schemeClr val="lt1"/>
+                  <a:srgbClr val="FFC000"/>
                 </a:solidFill>
               </a:ln>
               <a:effectLst/>
               <a:sp3d contourW="25400">
                 <a:contourClr>
-                  <a:schemeClr val="lt1"/>
+                  <a:srgbClr val="FFC000"/>
                 </a:contourClr>
               </a:sp3d>
             </c:spPr>
@@ -6220,13 +6220,13 @@
               </a:solidFill>
               <a:ln w="25400">
                 <a:solidFill>
-                  <a:schemeClr val="lt1"/>
+                  <a:srgbClr val="FF0000"/>
                 </a:solidFill>
               </a:ln>
               <a:effectLst/>
               <a:sp3d contourW="25400">
                 <a:contourClr>
-                  <a:schemeClr val="lt1"/>
+                  <a:srgbClr val="FF0000"/>
                 </a:contourClr>
               </a:sp3d>
             </c:spPr>
@@ -6439,13 +6439,13 @@
               </a:solidFill>
               <a:ln w="25400">
                 <a:solidFill>
-                  <a:schemeClr val="lt1"/>
+                  <a:schemeClr val="accent1"/>
                 </a:solidFill>
               </a:ln>
               <a:effectLst/>
               <a:sp3d contourW="25400">
                 <a:contourClr>
-                  <a:schemeClr val="lt1"/>
+                  <a:schemeClr val="accent1"/>
                 </a:contourClr>
               </a:sp3d>
             </c:spPr>
@@ -6464,13 +6464,13 @@
               </a:solidFill>
               <a:ln w="25400">
                 <a:solidFill>
-                  <a:schemeClr val="lt1"/>
+                  <a:schemeClr val="accent2"/>
                 </a:solidFill>
               </a:ln>
               <a:effectLst/>
               <a:sp3d contourW="25400">
                 <a:contourClr>
-                  <a:schemeClr val="lt1"/>
+                  <a:schemeClr val="accent2"/>
                 </a:contourClr>
               </a:sp3d>
             </c:spPr>
@@ -6489,13 +6489,13 @@
               </a:solidFill>
               <a:ln w="25400">
                 <a:solidFill>
-                  <a:schemeClr val="lt1"/>
+                  <a:schemeClr val="accent3"/>
                 </a:solidFill>
               </a:ln>
               <a:effectLst/>
               <a:sp3d contourW="25400">
                 <a:contourClr>
-                  <a:schemeClr val="lt1"/>
+                  <a:schemeClr val="accent3"/>
                 </a:contourClr>
               </a:sp3d>
             </c:spPr>
@@ -6514,13 +6514,13 @@
               </a:solidFill>
               <a:ln w="25400">
                 <a:solidFill>
-                  <a:schemeClr val="lt1"/>
+                  <a:schemeClr val="accent4"/>
                 </a:solidFill>
               </a:ln>
               <a:effectLst/>
               <a:sp3d contourW="25400">
                 <a:contourClr>
-                  <a:schemeClr val="lt1"/>
+                  <a:schemeClr val="accent4"/>
                 </a:contourClr>
               </a:sp3d>
             </c:spPr>

</xml_diff>

<commit_message>
fix(pptx): scope back bandeau strip to Inès' actual feedback (v2.4.6)
Régression introduite par v2.4.5 : j'avais extrapolé le feedback d'Inès
à 3 slides analysis-block et aux 6 slides commercial-closing. Erreur.

Inès ne demandait de retirer le bandeau que sur :
- slide 6 du livrable = analysis-block idx 2 (Évaluation globale)
- slides 33-34 du livrable = commercial-closing idx 4, 5 (murs logos)

Cette PR restaure le bandeau sur :
- analysis-block slides 0, 1 (Evaluation de la formation, Questions fiche)
- commercial-closing slides 0, 1, 2, 3 (Merci, Certifs, Actions, Encore une question)

Strict scope = ce qui a été explicitement flaggé, rien de plus.

Co-Authored-By: Claude Opus 4.7 (1M context) <noreply@anthropic.com>
</commit_message>
<xml_diff>
--- a/templates/analysis-block.pptx
+++ b/templates/analysis-block.pptx
@@ -38903,6 +38903,157 @@
           </a:p>
         </p:txBody>
       </p:sp>
+      <p:sp>
+        <p:nvSpPr>
+          <p:cNvPr id="56325" name="PIC_Bandeau_Line"/>
+          <p:cNvSpPr>
+            <a:spLocks noChangeShapeType="1"/>
+          </p:cNvSpPr>
+          <p:nvPr/>
+        </p:nvSpPr>
+        <p:spPr bwMode="auto">
+          <a:xfrm>
+            <a:off x="622300" y="687388"/>
+            <a:ext cx="10769600" cy="0"/>
+          </a:xfrm>
+          <a:prstGeom prst="line">
+            <a:avLst/>
+          </a:prstGeom>
+          <a:noFill/>
+          <a:ln w="19050">
+            <a:solidFill>
+              <a:srgbClr val="0070C0"/>
+            </a:solidFill>
+            <a:round/>
+            <a:headEnd/>
+            <a:tailEnd/>
+          </a:ln>
+        </p:spPr>
+        <p:txBody>
+          <a:bodyPr/>
+          <a:lstStyle/>
+          <a:p>
+            <a:endParaRPr lang="fr-FR"/>
+          </a:p>
+        </p:txBody>
+      </p:sp>
+      <p:sp>
+        <p:nvSpPr>
+          <p:cNvPr id="56326" name="PIC_Bandeau_Rect_Top"/>
+          <p:cNvSpPr>
+            <a:spLocks noChangeArrowheads="1"/>
+          </p:cNvSpPr>
+          <p:nvPr/>
+        </p:nvSpPr>
+        <p:spPr bwMode="auto">
+          <a:xfrm>
+            <a:off x="0" y="-9128"/>
+            <a:ext cx="152400" cy="2295128"/>
+          </a:xfrm>
+          <a:prstGeom prst="rect">
+            <a:avLst/>
+          </a:prstGeom>
+          <a:solidFill>
+            <a:srgbClr val="99CC00"/>
+          </a:solidFill>
+          <a:ln>
+            <a:noFill/>
+          </a:ln>
+        </p:spPr>
+        <p:txBody>
+          <a:bodyPr wrap="none" anchor="ctr"/>
+          <a:lstStyle/>
+          <a:p>
+            <a:endParaRPr lang="fr-FR"/>
+          </a:p>
+        </p:txBody>
+      </p:sp>
+      <p:sp>
+        <p:nvSpPr>
+          <p:cNvPr id="56327" name="PIC_Bandeau_Rect_Mid"/>
+          <p:cNvSpPr>
+            <a:spLocks noChangeArrowheads="1"/>
+          </p:cNvSpPr>
+          <p:nvPr/>
+        </p:nvSpPr>
+        <p:spPr bwMode="auto">
+          <a:xfrm>
+            <a:off x="0" y="2286000"/>
+            <a:ext cx="152400" cy="2286000"/>
+          </a:xfrm>
+          <a:prstGeom prst="rect">
+            <a:avLst/>
+          </a:prstGeom>
+          <a:solidFill>
+            <a:srgbClr val="0070C0"/>
+          </a:solidFill>
+          <a:ln>
+            <a:noFill/>
+          </a:ln>
+        </p:spPr>
+        <p:txBody>
+          <a:bodyPr wrap="none" anchor="ctr"/>
+          <a:lstStyle/>
+          <a:p>
+            <a:endParaRPr lang="fr-FR"/>
+          </a:p>
+        </p:txBody>
+      </p:sp>
+      <p:sp>
+        <p:nvSpPr>
+          <p:cNvPr id="56328" name="PIC_Bandeau_Rect_Bot"/>
+          <p:cNvSpPr>
+            <a:spLocks noChangeArrowheads="1"/>
+          </p:cNvSpPr>
+          <p:nvPr/>
+        </p:nvSpPr>
+        <p:spPr bwMode="auto">
+          <a:xfrm>
+            <a:off x="0" y="4560886"/>
+            <a:ext cx="152400" cy="2286000"/>
+          </a:xfrm>
+          <a:prstGeom prst="rect">
+            <a:avLst/>
+          </a:prstGeom>
+          <a:solidFill>
+            <a:srgbClr val="FF6600"/>
+          </a:solidFill>
+          <a:ln>
+            <a:noFill/>
+          </a:ln>
+        </p:spPr>
+        <p:txBody>
+          <a:bodyPr wrap="none" anchor="ctr"/>
+          <a:lstStyle/>
+          <a:p>
+            <a:endParaRPr lang="fr-FR"/>
+          </a:p>
+        </p:txBody>
+      </p:sp>
+      <p:pic>
+        <p:nvPicPr>
+          <p:cNvPr id="56329" name="PIC_Bandeau_Logo" descr="image.jpeg"/>
+          <p:cNvPicPr>
+            <a:picLocks noChangeAspect="1"/>
+          </p:cNvPicPr>
+          <p:nvPr/>
+        </p:nvPicPr>
+        <p:blipFill>
+          <a:blip r:embed="rId4"/>
+          <a:stretch>
+            <a:fillRect/>
+          </a:stretch>
+        </p:blipFill>
+        <p:spPr>
+          <a:xfrm>
+            <a:off x="11470314" y="20203"/>
+            <a:ext cx="721686" cy="720000"/>
+          </a:xfrm>
+          <a:prstGeom prst="rect">
+            <a:avLst/>
+          </a:prstGeom>
+        </p:spPr>
+      </p:pic>
     </p:spTree>
     <p:extLst>
       <p:ext uri="{BB962C8B-B14F-4D97-AF65-F5344CB8AC3E}">
@@ -42348,6 +42499,157 @@
           <a:xfrm>
             <a:off x="537328" y="785862"/>
             <a:ext cx="9782125" cy="5992819"/>
+          </a:xfrm>
+          <a:prstGeom prst="rect">
+            <a:avLst/>
+          </a:prstGeom>
+        </p:spPr>
+      </p:pic>
+      <p:sp>
+        <p:nvSpPr>
+          <p:cNvPr id="7" name="PIC_Bandeau_Line"/>
+          <p:cNvSpPr>
+            <a:spLocks noChangeShapeType="1"/>
+          </p:cNvSpPr>
+          <p:nvPr/>
+        </p:nvSpPr>
+        <p:spPr bwMode="auto">
+          <a:xfrm>
+            <a:off x="622300" y="687388"/>
+            <a:ext cx="10769600" cy="0"/>
+          </a:xfrm>
+          <a:prstGeom prst="line">
+            <a:avLst/>
+          </a:prstGeom>
+          <a:noFill/>
+          <a:ln w="19050">
+            <a:solidFill>
+              <a:srgbClr val="0070C0"/>
+            </a:solidFill>
+            <a:round/>
+            <a:headEnd/>
+            <a:tailEnd/>
+          </a:ln>
+        </p:spPr>
+        <p:txBody>
+          <a:bodyPr/>
+          <a:lstStyle/>
+          <a:p>
+            <a:endParaRPr lang="fr-FR"/>
+          </a:p>
+        </p:txBody>
+      </p:sp>
+      <p:sp>
+        <p:nvSpPr>
+          <p:cNvPr id="8" name="PIC_Bandeau_Rect_Top"/>
+          <p:cNvSpPr>
+            <a:spLocks noChangeArrowheads="1"/>
+          </p:cNvSpPr>
+          <p:nvPr/>
+        </p:nvSpPr>
+        <p:spPr bwMode="auto">
+          <a:xfrm>
+            <a:off x="0" y="-9128"/>
+            <a:ext cx="152400" cy="2295128"/>
+          </a:xfrm>
+          <a:prstGeom prst="rect">
+            <a:avLst/>
+          </a:prstGeom>
+          <a:solidFill>
+            <a:srgbClr val="99CC00"/>
+          </a:solidFill>
+          <a:ln>
+            <a:noFill/>
+          </a:ln>
+        </p:spPr>
+        <p:txBody>
+          <a:bodyPr wrap="none" anchor="ctr"/>
+          <a:lstStyle/>
+          <a:p>
+            <a:endParaRPr lang="fr-FR"/>
+          </a:p>
+        </p:txBody>
+      </p:sp>
+      <p:sp>
+        <p:nvSpPr>
+          <p:cNvPr id="9" name="PIC_Bandeau_Rect_Mid"/>
+          <p:cNvSpPr>
+            <a:spLocks noChangeArrowheads="1"/>
+          </p:cNvSpPr>
+          <p:nvPr/>
+        </p:nvSpPr>
+        <p:spPr bwMode="auto">
+          <a:xfrm>
+            <a:off x="0" y="2286000"/>
+            <a:ext cx="152400" cy="2286000"/>
+          </a:xfrm>
+          <a:prstGeom prst="rect">
+            <a:avLst/>
+          </a:prstGeom>
+          <a:solidFill>
+            <a:srgbClr val="0070C0"/>
+          </a:solidFill>
+          <a:ln>
+            <a:noFill/>
+          </a:ln>
+        </p:spPr>
+        <p:txBody>
+          <a:bodyPr wrap="none" anchor="ctr"/>
+          <a:lstStyle/>
+          <a:p>
+            <a:endParaRPr lang="fr-FR"/>
+          </a:p>
+        </p:txBody>
+      </p:sp>
+      <p:sp>
+        <p:nvSpPr>
+          <p:cNvPr id="10" name="PIC_Bandeau_Rect_Bot"/>
+          <p:cNvSpPr>
+            <a:spLocks noChangeArrowheads="1"/>
+          </p:cNvSpPr>
+          <p:nvPr/>
+        </p:nvSpPr>
+        <p:spPr bwMode="auto">
+          <a:xfrm>
+            <a:off x="0" y="4560886"/>
+            <a:ext cx="152400" cy="2286000"/>
+          </a:xfrm>
+          <a:prstGeom prst="rect">
+            <a:avLst/>
+          </a:prstGeom>
+          <a:solidFill>
+            <a:srgbClr val="FF6600"/>
+          </a:solidFill>
+          <a:ln>
+            <a:noFill/>
+          </a:ln>
+        </p:spPr>
+        <p:txBody>
+          <a:bodyPr wrap="none" anchor="ctr"/>
+          <a:lstStyle/>
+          <a:p>
+            <a:endParaRPr lang="fr-FR"/>
+          </a:p>
+        </p:txBody>
+      </p:sp>
+      <p:pic>
+        <p:nvPicPr>
+          <p:cNvPr id="11" name="PIC_Bandeau_Logo" descr="image.jpeg"/>
+          <p:cNvPicPr>
+            <a:picLocks noChangeAspect="1"/>
+          </p:cNvPicPr>
+          <p:nvPr/>
+        </p:nvPicPr>
+        <p:blipFill>
+          <a:blip r:embed="rId4"/>
+          <a:stretch>
+            <a:fillRect/>
+          </a:stretch>
+        </p:blipFill>
+        <p:spPr>
+          <a:xfrm>
+            <a:off x="11470314" y="20203"/>
+            <a:ext cx="721686" cy="720000"/>
           </a:xfrm>
           <a:prstGeom prst="rect">
             <a:avLst/>

</xml_diff>

<commit_message>
fix(pptx): puces carrées Wingdings inline sur slide Evaluation (v2.4.7)
Inès flag : "Slide 4 (Evaluation de la formation) : les puces ne sont
pas conformes à notre charte graphique."

Cause : le clone cross-PPTX perd l'héritage slideLayout47 du golden
Pic (qui définissait buFont=Wingdings + buChar=q, soit ❑ carré).
Notre slide carry déjà <a:buClr>0070C0</a:buClr> en pPr inline (bleu)
mais sans buFont/buChar → pas de puce visible côté livrable.

Fix : embed buFont + buChar inline dans chaque <a:pPr> du Rectangle 3
de la slide 0 de analysis-block.pptx (9 paragraphes patchés). Spec
extraite de MALECOT/slideLayout47/ph idx=1.

Patche aussi patch_branding_v3.py avec une fonction idempotente
`force_inline_square_bullets` appelée sur slide 0 à chaque rebuild.

Co-Authored-By: Claude Opus 4.7 (1M context) <noreply@anthropic.com>
</commit_message>
<xml_diff>
--- a/templates/analysis-block.pptx
+++ b/templates/analysis-block.pptx
@@ -38708,6 +38708,8 @@
               <a:buClr>
                 <a:srgbClr val="0070C0"/>
               </a:buClr>
+              <a:buFont typeface="Wingdings" pitchFamily="2" charset="2"/>
+              <a:buChar char="q"/>
             </a:pPr>
             <a:r>
               <a:rPr lang="fr-FR" sz="1600" dirty="0"/>
@@ -38722,6 +38724,8 @@
               <a:buClr>
                 <a:srgbClr val="0070C0"/>
               </a:buClr>
+              <a:buFont typeface="Wingdings" pitchFamily="2" charset="2"/>
+              <a:buChar char="q"/>
             </a:pPr>
             <a:endParaRPr lang="fr-FR" sz="1600" dirty="0"/>
           </a:p>
@@ -38733,6 +38737,8 @@
               <a:buClr>
                 <a:srgbClr val="0070C0"/>
               </a:buClr>
+              <a:buFont typeface="Wingdings" pitchFamily="2" charset="2"/>
+              <a:buChar char="q"/>
             </a:pPr>
             <a:r>
               <a:rPr lang="fr-FR" sz="1600" dirty="0"/>
@@ -38747,6 +38753,8 @@
               <a:buClr>
                 <a:srgbClr val="0070C0"/>
               </a:buClr>
+              <a:buFont typeface="Wingdings" pitchFamily="2" charset="2"/>
+              <a:buChar char="q"/>
             </a:pPr>
             <a:endParaRPr lang="fr-FR" sz="1600" dirty="0"/>
           </a:p>
@@ -38758,6 +38766,8 @@
               <a:buClr>
                 <a:srgbClr val="0070C0"/>
               </a:buClr>
+              <a:buFont typeface="Wingdings" pitchFamily="2" charset="2"/>
+              <a:buChar char="q"/>
             </a:pPr>
             <a:r>
               <a:rPr lang="fr-FR" sz="1600" dirty="0"/>
@@ -38772,6 +38782,8 @@
               <a:buClr>
                 <a:srgbClr val="0070C0"/>
               </a:buClr>
+              <a:buFont typeface="Wingdings" pitchFamily="2" charset="2"/>
+              <a:buChar char="q"/>
             </a:pPr>
             <a:endParaRPr lang="fr-FR" sz="1600" dirty="0"/>
           </a:p>
@@ -38783,6 +38795,8 @@
               <a:buClr>
                 <a:srgbClr val="0070C0"/>
               </a:buClr>
+              <a:buFont typeface="Wingdings" pitchFamily="2" charset="2"/>
+              <a:buChar char="q"/>
             </a:pPr>
             <a:r>
               <a:rPr lang="fr-FR" sz="1600" dirty="0"/>
@@ -38797,6 +38811,8 @@
               <a:buClr>
                 <a:srgbClr val="0070C0"/>
               </a:buClr>
+              <a:buFont typeface="Wingdings" pitchFamily="2" charset="2"/>
+              <a:buChar char="q"/>
             </a:pPr>
             <a:endParaRPr lang="fr-FR" sz="1600" dirty="0"/>
           </a:p>
@@ -38808,6 +38824,8 @@
               <a:buClr>
                 <a:srgbClr val="0070C0"/>
               </a:buClr>
+              <a:buFont typeface="Wingdings" pitchFamily="2" charset="2"/>
+              <a:buChar char="q"/>
             </a:pPr>
             <a:r>
               <a:rPr lang="fr-FR" sz="1600" dirty="0"/>

</xml_diff>